<commit_message>
System Design vi: fix review findings on sd-11-033
- figure: separate user accounts (RDS) from IAM permissions
- quiz asks for two services, matching the answer
- metadata claim points at the AWS documentation

Co-Authored-By: Claude Sonnet 5.5 <noreply@anthropic.com>
Claude-Session: https://claude.ai/code/session_01FUEjJx1iJbs8YafmDVXup4
</commit_message>
<xml_diff>
--- a/system-design-101/vi/lessons/sd-11-033/slides/sd-11-033.pptx
+++ b/system-design-101/vi/lessons/sd-11-033/slides/sd-11-033.pptx
@@ -9463,7 +9463,7 @@
               <a:t> hai</a:t>
             </a:r>
             <a:r>
-              <a:rPr lang="en-US" sz="6300" dirty="0" spc="3" kern="0">
+              <a:rPr lang="en-US" sz="6300" dirty="0" spc="1" kern="0">
                 <a:solidFill>
                   <a:srgbClr val="F3EEE3"/>
                 </a:solidFill>
@@ -9471,18 +9471,7 @@
                 <a:ea typeface="Bricolage Grotesque ExtraBold" pitchFamily="34" charset="-122"/>
                 <a:cs typeface="Bricolage Grotesque ExtraBold" pitchFamily="34" charset="-120"/>
               </a:rPr>
-              <a:t> nhóm</a:t>
-            </a:r>
-            <a:r>
-              <a:rPr lang="en-US" sz="6300" dirty="0" spc="1" kern="0">
-                <a:solidFill>
-                  <a:srgbClr val="F3EEE3"/>
-                </a:solidFill>
-                <a:latin typeface="Bricolage Grotesque ExtraBold" pitchFamily="34" charset="0"/>
-                <a:ea typeface="Bricolage Grotesque ExtraBold" pitchFamily="34" charset="-122"/>
-                <a:cs typeface="Bricolage Grotesque ExtraBold" pitchFamily="34" charset="-120"/>
-              </a:rPr>
-              <a:t> nào</a:t>
+              <a:t> dịch vụ nào</a:t>
             </a:r>
             <a:r>
               <a:rPr lang="en-US" sz="6300" dirty="0" spc="-77" kern="0">
@@ -9528,7 +9517,7 @@
       </p:sp>
       <p:sp>
         <p:nvSpPr>
-          <p:cNvPr id="5" name="Text richtext-1792423700391-555119500"/>
+          <p:cNvPr id="5" name="Text richtext-1792424388119-40464132"/>
           <p:cNvSpPr/>
           <p:nvPr/>
         </p:nvSpPr>

</xml_diff>

<commit_message>
System Design vi: sd-11-033 quiz asks for the network control, with IAM scoped to who may change it
Co-Authored-By: Claude Sonnet 5.5 <noreply@anthropic.com>
Claude-Session: https://claude.ai/code/session_01FUEjJx1iJbs8YafmDVXup4
</commit_message>
<xml_diff>
--- a/system-design-101/vi/lessons/sd-11-033/slides/sd-11-033.pptx
+++ b/system-design-101/vi/lessons/sd-11-033/slides/sd-11-033.pptx
@@ -9397,7 +9397,7 @@
               <a:buNone/>
             </a:pPr>
             <a:r>
-              <a:rPr lang="en-US" sz="6300" dirty="0" spc="0" kern="0">
+              <a:rPr lang="en-US" sz="6300" dirty="0" spc="-2" kern="0">
                 <a:solidFill>
                   <a:srgbClr val="F3EEE3"/>
                 </a:solidFill>
@@ -9405,10 +9405,10 @@
                 <a:ea typeface="Bricolage Grotesque ExtraBold" pitchFamily="34" charset="-122"/>
                 <a:cs typeface="Bricolage Grotesque ExtraBold" pitchFamily="34" charset="-120"/>
               </a:rPr>
-              <a:t>Mạng</a:t>
-            </a:r>
-            <a:r>
-              <a:rPr lang="en-US" sz="6300" dirty="0" spc="-1" kern="0">
+              <a:t>Máy</a:t>
+            </a:r>
+            <a:r>
+              <a:rPr lang="en-US" sz="6300" dirty="0" spc="0" kern="0">
                 <a:solidFill>
                   <a:srgbClr val="F3EEE3"/>
                 </a:solidFill>
@@ -9416,10 +9416,10 @@
                 <a:ea typeface="Bricolage Grotesque ExtraBold" pitchFamily="34" charset="-122"/>
                 <a:cs typeface="Bricolage Grotesque ExtraBold" pitchFamily="34" charset="-120"/>
               </a:rPr>
-              <a:t> ai cũng</a:t>
-            </a:r>
-            <a:r>
-              <a:rPr lang="en-US" sz="6300" dirty="0" spc="-50" kern="0">
+              <a:t> chủ ai</a:t>
+            </a:r>
+            <a:r>
+              <a:rPr lang="en-US" sz="6300" dirty="0" spc="-1" kern="0">
                 <a:solidFill>
                   <a:srgbClr val="F3EEE3"/>
                 </a:solidFill>
@@ -9427,10 +9427,10 @@
                 <a:ea typeface="Bricolage Grotesque ExtraBold" pitchFamily="34" charset="-122"/>
                 <a:cs typeface="Bricolage Grotesque ExtraBold" pitchFamily="34" charset="-120"/>
               </a:rPr>
-              <a:t> vào</a:t>
-            </a:r>
-            <a:r>
-              <a:rPr lang="en-US" sz="6300" dirty="0" spc="-63" kern="0">
+              <a:t> cũng</a:t>
+            </a:r>
+            <a:r>
+              <a:rPr lang="en-US" sz="6300" dirty="0" spc="-36" kern="0">
                 <a:solidFill>
                   <a:srgbClr val="F3EEE3"/>
                 </a:solidFill>
@@ -9438,10 +9438,10 @@
                 <a:ea typeface="Bricolage Grotesque ExtraBold" pitchFamily="34" charset="-122"/>
                 <a:cs typeface="Bricolage Grotesque ExtraBold" pitchFamily="34" charset="-120"/>
               </a:rPr>
-              <a:t> được:</a:t>
-            </a:r>
-            <a:r>
-              <a:rPr lang="en-US" sz="6300" dirty="0" spc="0" kern="0">
+              <a:t> kết</a:t>
+            </a:r>
+            <a:r>
+              <a:rPr lang="en-US" sz="6300" dirty="0" spc="1" kern="0">
                 <a:solidFill>
                   <a:srgbClr val="F3EEE3"/>
                 </a:solidFill>
@@ -9449,10 +9449,10 @@
                 <a:ea typeface="Bricolage Grotesque ExtraBold" pitchFamily="34" charset="-122"/>
                 <a:cs typeface="Bricolage Grotesque ExtraBold" pitchFamily="34" charset="-120"/>
               </a:rPr>
-              <a:t> học</a:t>
-            </a:r>
-            <a:r>
-              <a:rPr lang="en-US" sz="6300" dirty="0" spc="2" kern="0">
+              <a:t> nối</a:t>
+            </a:r>
+            <a:r>
+              <a:rPr lang="en-US" sz="6300" dirty="0" spc="-63" kern="0">
                 <a:solidFill>
                   <a:srgbClr val="F3EEE3"/>
                 </a:solidFill>
@@ -9460,7 +9460,7 @@
                 <a:ea typeface="Bricolage Grotesque ExtraBold" pitchFamily="34" charset="-122"/>
                 <a:cs typeface="Bricolage Grotesque ExtraBold" pitchFamily="34" charset="-120"/>
               </a:rPr>
-              <a:t> hai</a:t>
+              <a:t> được:</a:t>
             </a:r>
             <a:r>
               <a:rPr lang="en-US" sz="6300" dirty="0" spc="1" kern="0">
@@ -9471,10 +9471,10 @@
                 <a:ea typeface="Bricolage Grotesque ExtraBold" pitchFamily="34" charset="-122"/>
                 <a:cs typeface="Bricolage Grotesque ExtraBold" pitchFamily="34" charset="-120"/>
               </a:rPr>
-              <a:t> dịch vụ nào</a:t>
-            </a:r>
-            <a:r>
-              <a:rPr lang="en-US" sz="6300" dirty="0" spc="-77" kern="0">
+              <a:t> dịch vụ</a:t>
+            </a:r>
+            <a:r>
+              <a:rPr lang="en-US" sz="6300" dirty="0" spc="2" kern="0">
                 <a:solidFill>
                   <a:srgbClr val="F3EEE3"/>
                 </a:solidFill>
@@ -9482,7 +9482,18 @@
                 <a:ea typeface="Bricolage Grotesque ExtraBold" pitchFamily="34" charset="-122"/>
                 <a:cs typeface="Bricolage Grotesque ExtraBold" pitchFamily="34" charset="-120"/>
               </a:rPr>
-              <a:t> trước?</a:t>
+              <a:t> nào</a:t>
+            </a:r>
+            <a:r>
+              <a:rPr lang="en-US" sz="6300" dirty="0" spc="8" kern="0">
+                <a:solidFill>
+                  <a:srgbClr val="F3EEE3"/>
+                </a:solidFill>
+                <a:latin typeface="Bricolage Grotesque ExtraBold" pitchFamily="34" charset="0"/>
+                <a:ea typeface="Bricolage Grotesque ExtraBold" pitchFamily="34" charset="-122"/>
+                <a:cs typeface="Bricolage Grotesque ExtraBold" pitchFamily="34" charset="-120"/>
+              </a:rPr>
+              <a:t> đóng?</a:t>
             </a:r>
             <a:endParaRPr lang="en-US" sz="6300" dirty="0"/>
           </a:p>
@@ -9497,11 +9508,11 @@
         <p:spPr>
           <a:xfrm>
             <a:off x="914400" y="5143500"/>
-            <a:ext cx="16459200" cy="2857500"/>
+            <a:ext cx="16459200" cy="3143250"/>
           </a:xfrm>
           <a:prstGeom prst="roundRect">
             <a:avLst>
-              <a:gd name="adj" fmla="val 9333"/>
+              <a:gd name="adj" fmla="val 8485"/>
             </a:avLst>
           </a:prstGeom>
           <a:solidFill>
@@ -9517,14 +9528,14 @@
       </p:sp>
       <p:sp>
         <p:nvSpPr>
-          <p:cNvPr id="5" name="Text richtext-1792424388119-40464132"/>
+          <p:cNvPr id="5" name="Text richtext-1792425637701-253677548"/>
           <p:cNvSpPr/>
           <p:nvPr/>
         </p:nvSpPr>
         <p:spPr>
           <a:xfrm>
             <a:off x="1333500" y="5334000"/>
-            <a:ext cx="15621000" cy="2476500"/>
+            <a:ext cx="15621000" cy="2762250"/>
           </a:xfrm>
           <a:prstGeom prst="rect">
             <a:avLst/>
@@ -9542,7 +9553,7 @@
               <a:buChar char="•"/>
             </a:pPr>
             <a:r>
-              <a:rPr lang="en-US" sz="3000" dirty="0" spc="-2" kern="0">
+              <a:rPr lang="en-US" sz="3000" dirty="0" spc="-1" kern="0">
                 <a:solidFill>
                   <a:srgbClr val="F3EEE3"/>
                 </a:solidFill>
@@ -9550,10 +9561,10 @@
                 <a:ea typeface="Be Vietnam Pro" pitchFamily="34" charset="-122"/>
                 <a:cs typeface="Be Vietnam Pro" pitchFamily="34" charset="-120"/>
               </a:rPr>
-              <a:t>Mạng</a:t>
-            </a:r>
-            <a:r>
-              <a:rPr lang="en-US" sz="3000" dirty="0" spc="2" kern="0">
+              <a:t>VPC:</a:t>
+            </a:r>
+            <a:r>
+              <a:rPr lang="en-US" sz="3000" dirty="0" spc="-22" kern="0">
                 <a:solidFill>
                   <a:srgbClr val="F3EEE3"/>
                 </a:solidFill>
@@ -9561,10 +9572,10 @@
                 <a:ea typeface="Be Vietnam Pro" pitchFamily="34" charset="-122"/>
                 <a:cs typeface="Be Vietnam Pro" pitchFamily="34" charset="-120"/>
               </a:rPr>
-              <a:t> (VPC)</a:t>
-            </a:r>
-            <a:r>
-              <a:rPr lang="en-US" sz="3000" dirty="0" spc="-20" kern="0">
+              <a:t> quyết</a:t>
+            </a:r>
+            <a:r>
+              <a:rPr lang="en-US" sz="3000" dirty="0" spc="23" kern="0">
                 <a:solidFill>
                   <a:srgbClr val="F3EEE3"/>
                 </a:solidFill>
@@ -9572,10 +9583,10 @@
                 <a:ea typeface="Be Vietnam Pro" pitchFamily="34" charset="-122"/>
                 <a:cs typeface="Be Vietnam Pro" pitchFamily="34" charset="-120"/>
               </a:rPr>
-              <a:t> và</a:t>
-            </a:r>
-            <a:r>
-              <a:rPr lang="en-US" sz="3000" dirty="0" spc="23" kern="0">
+              <a:t> định</a:t>
+            </a:r>
+            <a:r>
+              <a:rPr lang="en-US" sz="3000" dirty="0" spc="25" kern="0">
                 <a:solidFill>
                   <a:srgbClr val="F3EEE3"/>
                 </a:solidFill>
@@ -9583,10 +9594,10 @@
                 <a:ea typeface="Be Vietnam Pro" pitchFamily="34" charset="-122"/>
                 <a:cs typeface="Be Vietnam Pro" pitchFamily="34" charset="-120"/>
               </a:rPr>
-              <a:t> định</a:t>
-            </a:r>
-            <a:r>
-              <a:rPr lang="en-US" sz="3000" dirty="0" spc="1" kern="0">
+              <a:t> lưu</a:t>
+            </a:r>
+            <a:r>
+              <a:rPr lang="en-US" sz="3000" dirty="0" spc="9" kern="0">
                 <a:solidFill>
                   <a:srgbClr val="F3EEE3"/>
                 </a:solidFill>
@@ -9594,7 +9605,40 @@
                 <a:ea typeface="Be Vietnam Pro" pitchFamily="34" charset="-122"/>
                 <a:cs typeface="Be Vietnam Pro" pitchFamily="34" charset="-120"/>
               </a:rPr>
-              <a:t> danh</a:t>
+              <a:t> lượng</a:t>
+            </a:r>
+            <a:r>
+              <a:rPr lang="en-US" sz="3000" dirty="0" spc="-1" kern="0">
+                <a:solidFill>
+                  <a:srgbClr val="F3EEE3"/>
+                </a:solidFill>
+                <a:latin typeface="Be Vietnam Pro" pitchFamily="34" charset="0"/>
+                <a:ea typeface="Be Vietnam Pro" pitchFamily="34" charset="-122"/>
+                <a:cs typeface="Be Vietnam Pro" pitchFamily="34" charset="-120"/>
+              </a:rPr>
+              <a:t> nào</a:t>
+            </a:r>
+            <a:r>
+              <a:rPr lang="en-US" sz="3000" dirty="0" spc="-13" kern="0">
+                <a:solidFill>
+                  <a:srgbClr val="F3EEE3"/>
+                </a:solidFill>
+                <a:latin typeface="Be Vietnam Pro" pitchFamily="34" charset="0"/>
+                <a:ea typeface="Be Vietnam Pro" pitchFamily="34" charset="-122"/>
+                <a:cs typeface="Be Vietnam Pro" pitchFamily="34" charset="-120"/>
+              </a:rPr>
+              <a:t> tới</a:t>
+            </a:r>
+            <a:r>
+              <a:rPr lang="en-US" sz="3000" dirty="0" spc="-11" kern="0">
+                <a:solidFill>
+                  <a:srgbClr val="F3EEE3"/>
+                </a:solidFill>
+                <a:latin typeface="Be Vietnam Pro" pitchFamily="34" charset="0"/>
+                <a:ea typeface="Be Vietnam Pro" pitchFamily="34" charset="-122"/>
+                <a:cs typeface="Be Vietnam Pro" pitchFamily="34" charset="-120"/>
+              </a:rPr>
+              <a:t> máy</a:t>
             </a:r>
             <a:r>
               <a:rPr lang="en-US" sz="3000" dirty="0" spc="0" kern="0">
@@ -9605,7 +9649,7 @@
                 <a:ea typeface="Be Vietnam Pro" pitchFamily="34" charset="-122"/>
                 <a:cs typeface="Be Vietnam Pro" pitchFamily="34" charset="-120"/>
               </a:rPr>
-              <a:t> (IAM).</a:t>
+              <a:t> chủ.</a:t>
             </a:r>
             <a:endParaRPr lang="en-US" sz="3000" dirty="0"/>
           </a:p>
@@ -9616,6 +9660,28 @@
               <a:buChar char="•"/>
             </a:pPr>
             <a:r>
+              <a:rPr lang="en-US" sz="3000" dirty="0" spc="-3" kern="0">
+                <a:solidFill>
+                  <a:srgbClr val="F3EEE3"/>
+                </a:solidFill>
+                <a:latin typeface="Be Vietnam Pro" pitchFamily="34" charset="0"/>
+                <a:ea typeface="Be Vietnam Pro" pitchFamily="34" charset="-122"/>
+                <a:cs typeface="Be Vietnam Pro" pitchFamily="34" charset="-120"/>
+              </a:rPr>
+              <a:t>IAM</a:t>
+            </a:r>
+            <a:r>
+              <a:rPr lang="en-US" sz="3000" dirty="0" spc="1" kern="0">
+                <a:solidFill>
+                  <a:srgbClr val="F3EEE3"/>
+                </a:solidFill>
+                <a:latin typeface="Be Vietnam Pro" pitchFamily="34" charset="0"/>
+                <a:ea typeface="Be Vietnam Pro" pitchFamily="34" charset="-122"/>
+                <a:cs typeface="Be Vietnam Pro" pitchFamily="34" charset="-120"/>
+              </a:rPr>
+              <a:t> không</a:t>
+            </a:r>
+            <a:r>
               <a:rPr lang="en-US" sz="3000" dirty="0" spc="0" kern="0">
                 <a:solidFill>
                   <a:srgbClr val="F3EEE3"/>
@@ -9624,7 +9690,59 @@
                 <a:ea typeface="Be Vietnam Pro" pitchFamily="34" charset="-122"/>
                 <a:cs typeface="Be Vietnam Pro" pitchFamily="34" charset="-120"/>
               </a:rPr>
-              <a:t>VPC</a:t>
+              <a:t> lọc</a:t>
+            </a:r>
+            <a:r>
+              <a:rPr lang="en-US" sz="3000" dirty="0" spc="24" kern="0">
+                <a:solidFill>
+                  <a:srgbClr val="F3EEE3"/>
+                </a:solidFill>
+                <a:latin typeface="Be Vietnam Pro" pitchFamily="34" charset="0"/>
+                <a:ea typeface="Be Vietnam Pro" pitchFamily="34" charset="-122"/>
+                <a:cs typeface="Be Vietnam Pro" pitchFamily="34" charset="-120"/>
+              </a:rPr>
+              <a:t> lưu</a:t>
+            </a:r>
+            <a:r>
+              <a:rPr lang="en-US" sz="3000" dirty="0" spc="9" kern="0">
+                <a:solidFill>
+                  <a:srgbClr val="F3EEE3"/>
+                </a:solidFill>
+                <a:latin typeface="Be Vietnam Pro" pitchFamily="34" charset="0"/>
+                <a:ea typeface="Be Vietnam Pro" pitchFamily="34" charset="-122"/>
+                <a:cs typeface="Be Vietnam Pro" pitchFamily="34" charset="-120"/>
+              </a:rPr>
+              <a:t> lượng</a:t>
+            </a:r>
+            <a:r>
+              <a:rPr lang="en-US" sz="3000" dirty="0" spc="0" kern="0">
+                <a:solidFill>
+                  <a:srgbClr val="F3EEE3"/>
+                </a:solidFill>
+                <a:latin typeface="Be Vietnam Pro" pitchFamily="34" charset="0"/>
+                <a:ea typeface="Be Vietnam Pro" pitchFamily="34" charset="-122"/>
+                <a:cs typeface="Be Vietnam Pro" pitchFamily="34" charset="-120"/>
+              </a:rPr>
+              <a:t> mạng.</a:t>
+            </a:r>
+            <a:endParaRPr lang="en-US" sz="3000" dirty="0"/>
+          </a:p>
+          <a:p>
+            <a:pPr algn="l" marL="381000" indent="-272202">
+              <a:buSzPct val="100000"/>
+              <a:buFont typeface="Arial"/>
+              <a:buChar char="•"/>
+            </a:pPr>
+            <a:r>
+              <a:rPr lang="en-US" sz="3000" dirty="0" spc="-3" kern="0">
+                <a:solidFill>
+                  <a:srgbClr val="F3EEE3"/>
+                </a:solidFill>
+                <a:latin typeface="Be Vietnam Pro" pitchFamily="34" charset="0"/>
+                <a:ea typeface="Be Vietnam Pro" pitchFamily="34" charset="-122"/>
+                <a:cs typeface="Be Vietnam Pro" pitchFamily="34" charset="-120"/>
+              </a:rPr>
+              <a:t>IAM:</a:t>
             </a:r>
             <a:r>
               <a:rPr lang="en-US" sz="3000" dirty="0" spc="2" kern="0">
@@ -9635,7 +9753,29 @@
                 <a:ea typeface="Be Vietnam Pro" pitchFamily="34" charset="-122"/>
                 <a:cs typeface="Be Vietnam Pro" pitchFamily="34" charset="-120"/>
               </a:rPr>
-              <a:t> chia</a:t>
+              <a:t> ai</a:t>
+            </a:r>
+            <a:r>
+              <a:rPr lang="en-US" sz="3000" dirty="0" spc="11" kern="0">
+                <a:solidFill>
+                  <a:srgbClr val="F3EEE3"/>
+                </a:solidFill>
+                <a:latin typeface="Be Vietnam Pro" pitchFamily="34" charset="0"/>
+                <a:ea typeface="Be Vietnam Pro" pitchFamily="34" charset="-122"/>
+                <a:cs typeface="Be Vietnam Pro" pitchFamily="34" charset="-120"/>
+              </a:rPr>
+              <a:t> được</a:t>
+            </a:r>
+            <a:r>
+              <a:rPr lang="en-US" sz="3000" dirty="0" spc="12" kern="0">
+                <a:solidFill>
+                  <a:srgbClr val="F3EEE3"/>
+                </a:solidFill>
+                <a:latin typeface="Be Vietnam Pro" pitchFamily="34" charset="0"/>
+                <a:ea typeface="Be Vietnam Pro" pitchFamily="34" charset="-122"/>
+                <a:cs typeface="Be Vietnam Pro" pitchFamily="34" charset="-120"/>
+              </a:rPr>
+              <a:t> sửa</a:t>
             </a:r>
             <a:r>
               <a:rPr lang="en-US" sz="3000" dirty="0" spc="0" kern="0">
@@ -9646,10 +9786,10 @@
                 <a:ea typeface="Be Vietnam Pro" pitchFamily="34" charset="-122"/>
                 <a:cs typeface="Be Vietnam Pro" pitchFamily="34" charset="-120"/>
               </a:rPr>
-              <a:t> mạng</a:t>
-            </a:r>
-            <a:r>
-              <a:rPr lang="en-US" sz="3000" dirty="0" spc="9" kern="0">
+              <a:t> các</a:t>
+            </a:r>
+            <a:r>
+              <a:rPr lang="en-US" sz="3000" dirty="0" spc="-5" kern="0">
                 <a:solidFill>
                   <a:srgbClr val="F3EEE3"/>
                 </a:solidFill>
@@ -9657,10 +9797,10 @@
                 <a:ea typeface="Be Vietnam Pro" pitchFamily="34" charset="-122"/>
                 <a:cs typeface="Be Vietnam Pro" pitchFamily="34" charset="-120"/>
               </a:rPr>
-              <a:t> riêng;</a:t>
-            </a:r>
-            <a:r>
-              <a:rPr lang="en-US" sz="3000" dirty="0" spc="-1" kern="0">
+              <a:t> thiết</a:t>
+            </a:r>
+            <a:r>
+              <a:rPr lang="en-US" sz="3000" dirty="0" spc="3" kern="0">
                 <a:solidFill>
                   <a:srgbClr val="F3EEE3"/>
                 </a:solidFill>
@@ -9668,10 +9808,10 @@
                 <a:ea typeface="Be Vietnam Pro" pitchFamily="34" charset="-122"/>
                 <a:cs typeface="Be Vietnam Pro" pitchFamily="34" charset="-120"/>
               </a:rPr>
-              <a:t> IAM</a:t>
-            </a:r>
-            <a:r>
-              <a:rPr lang="en-US" sz="3000" dirty="0" spc="1" kern="0">
+              <a:t> lập</a:t>
+            </a:r>
+            <a:r>
+              <a:rPr lang="en-US" sz="3000" dirty="0" spc="15" kern="0">
                 <a:solidFill>
                   <a:srgbClr val="F3EEE3"/>
                 </a:solidFill>
@@ -9679,18 +9819,7 @@
                 <a:ea typeface="Be Vietnam Pro" pitchFamily="34" charset="-122"/>
                 <a:cs typeface="Be Vietnam Pro" pitchFamily="34" charset="-120"/>
               </a:rPr>
-              <a:t> chia</a:t>
-            </a:r>
-            <a:r>
-              <a:rPr lang="en-US" sz="3000" dirty="0" spc="-15" kern="0">
-                <a:solidFill>
-                  <a:srgbClr val="F3EEE3"/>
-                </a:solidFill>
-                <a:latin typeface="Be Vietnam Pro" pitchFamily="34" charset="0"/>
-                <a:ea typeface="Be Vietnam Pro" pitchFamily="34" charset="-122"/>
-                <a:cs typeface="Be Vietnam Pro" pitchFamily="34" charset="-120"/>
-              </a:rPr>
-              <a:t> quyền.</a:t>
+              <a:t> đó.</a:t>
             </a:r>
             <a:endParaRPr lang="en-US" sz="3000" dirty="0"/>
           </a:p>

</xml_diff>

<commit_message>
System Design vi: sd-11-033 scope the VPC description to resources that run inside it
Co-Authored-By: Claude Sonnet 5.5 <noreply@anthropic.com>
Claude-Session: https://claude.ai/code/session_01FUEjJx1iJbs8YafmDVXup4
</commit_message>
<xml_diff>
--- a/system-design-101/vi/lessons/sd-11-033/slides/sd-11-033.pptx
+++ b/system-design-101/vi/lessons/sd-11-033/slides/sd-11-033.pptx
@@ -5160,7 +5160,7 @@
               <a:t> riêng</a:t>
             </a:r>
             <a:r>
-              <a:rPr lang="en-US" sz="2700" dirty="0" spc="-2" kern="0">
+              <a:rPr lang="en-US" sz="2700" dirty="0" spc="-1" kern="0">
                 <a:solidFill>
                   <a:srgbClr val="F3EEE3"/>
                 </a:solidFill>
@@ -5168,10 +5168,10 @@
                 <a:ea typeface="Be Vietnam Pro" pitchFamily="34" charset="-122"/>
                 <a:cs typeface="Be Vietnam Pro" pitchFamily="34" charset="-120"/>
               </a:rPr>
-              <a:t> của</a:t>
-            </a:r>
-            <a:r>
-              <a:rPr lang="en-US" sz="2700" dirty="0" spc="2" kern="0">
+              <a:t> cho</a:t>
+            </a:r>
+            <a:r>
+              <a:rPr lang="en-US" sz="2700" dirty="0" spc="-13" kern="0">
                 <a:solidFill>
                   <a:srgbClr val="F3EEE3"/>
                 </a:solidFill>
@@ -5179,10 +5179,10 @@
                 <a:ea typeface="Be Vietnam Pro" pitchFamily="34" charset="-122"/>
                 <a:cs typeface="Be Vietnam Pro" pitchFamily="34" charset="-120"/>
               </a:rPr>
-              <a:t> các</a:t>
-            </a:r>
-            <a:r>
-              <a:rPr lang="en-US" sz="2700" dirty="0" spc="-2" kern="0">
+              <a:t> tài</a:t>
+            </a:r>
+            <a:r>
+              <a:rPr lang="en-US" sz="2700" dirty="0" spc="-16" kern="0">
                 <a:solidFill>
                   <a:srgbClr val="F3EEE3"/>
                 </a:solidFill>
@@ -5190,10 +5190,10 @@
                 <a:ea typeface="Be Vietnam Pro" pitchFamily="34" charset="-122"/>
                 <a:cs typeface="Be Vietnam Pro" pitchFamily="34" charset="-120"/>
               </a:rPr>
-              <a:t> dịch</a:t>
-            </a:r>
-            <a:r>
-              <a:rPr lang="en-US" sz="2700" dirty="0" spc="-1" kern="0">
+              <a:t> nguyên</a:t>
+            </a:r>
+            <a:r>
+              <a:rPr lang="en-US" sz="2700" dirty="0" spc="-7" kern="0">
                 <a:solidFill>
                   <a:srgbClr val="F3EEE3"/>
                 </a:solidFill>
@@ -5201,7 +5201,29 @@
                 <a:ea typeface="Be Vietnam Pro" pitchFamily="34" charset="-122"/>
                 <a:cs typeface="Be Vietnam Pro" pitchFamily="34" charset="-120"/>
               </a:rPr>
-              <a:t> vụ.</a:t>
+              <a:t> chạy</a:t>
+            </a:r>
+            <a:r>
+              <a:rPr lang="en-US" sz="2700" dirty="0" spc="-20" kern="0">
+                <a:solidFill>
+                  <a:srgbClr val="F3EEE3"/>
+                </a:solidFill>
+                <a:latin typeface="Be Vietnam Pro" pitchFamily="34" charset="0"/>
+                <a:ea typeface="Be Vietnam Pro" pitchFamily="34" charset="-122"/>
+                <a:cs typeface="Be Vietnam Pro" pitchFamily="34" charset="-120"/>
+              </a:rPr>
+              <a:t> trong</a:t>
+            </a:r>
+            <a:r>
+              <a:rPr lang="en-US" sz="2700" dirty="0" spc="-3" kern="0">
+                <a:solidFill>
+                  <a:srgbClr val="F3EEE3"/>
+                </a:solidFill>
+                <a:latin typeface="Be Vietnam Pro" pitchFamily="34" charset="0"/>
+                <a:ea typeface="Be Vietnam Pro" pitchFamily="34" charset="-122"/>
+                <a:cs typeface="Be Vietnam Pro" pitchFamily="34" charset="-120"/>
+              </a:rPr>
+              <a:t> nó.</a:t>
             </a:r>
             <a:endParaRPr lang="en-US" sz="2700" dirty="0"/>
           </a:p>

</xml_diff>

<commit_message>
System Design vi: sd-11-033 present the four services as a representative starter set
Co-Authored-By: Claude Sonnet 5.5 <noreply@anthropic.com>
Claude-Session: https://claude.ai/code/session_01FUEjJx1iJbs8YafmDVXup4
</commit_message>
<xml_diff>
--- a/system-design-101/vi/lessons/sd-11-033/slides/sd-11-033.pptx
+++ b/system-design-101/vi/lessons/sd-11-033/slides/sd-11-033.pptx
@@ -4757,7 +4757,7 @@
               <a:buNone/>
             </a:pPr>
             <a:r>
-              <a:rPr lang="en-US" sz="6300" dirty="0" spc="2" kern="0">
+              <a:rPr lang="en-US" sz="6300" dirty="0" spc="-10" kern="0">
                 <a:solidFill>
                   <a:srgbClr val="F3EEE3"/>
                 </a:solidFill>
@@ -4765,10 +4765,10 @@
                 <a:ea typeface="Bricolage Grotesque ExtraBold" pitchFamily="34" charset="-122"/>
                 <a:cs typeface="Bricolage Grotesque ExtraBold" pitchFamily="34" charset="-120"/>
               </a:rPr>
-              <a:t>Bốn</a:t>
-            </a:r>
-            <a:r>
-              <a:rPr lang="en-US" sz="6300" dirty="0" spc="4" kern="0">
+              <a:t>Một</a:t>
+            </a:r>
+            <a:r>
+              <a:rPr lang="en-US" sz="6300" dirty="0" spc="1" kern="0">
                 <a:solidFill>
                   <a:srgbClr val="F3EEE3"/>
                 </a:solidFill>
@@ -4776,10 +4776,10 @@
                 <a:ea typeface="Bricolage Grotesque ExtraBold" pitchFamily="34" charset="-122"/>
                 <a:cs typeface="Bricolage Grotesque ExtraBold" pitchFamily="34" charset="-120"/>
               </a:rPr>
-              <a:t> thứ</a:t>
-            </a:r>
-            <a:r>
-              <a:rPr lang="en-US" sz="6300" dirty="0" spc="0" kern="0">
+              <a:t> bộ</a:t>
+            </a:r>
+            <a:r>
+              <a:rPr lang="en-US" sz="6300" dirty="0" spc="-22" kern="0">
                 <a:solidFill>
                   <a:srgbClr val="F3EEE3"/>
                 </a:solidFill>
@@ -4787,10 +4787,10 @@
                 <a:ea typeface="Bricolage Grotesque ExtraBold" pitchFamily="34" charset="-122"/>
                 <a:cs typeface="Bricolage Grotesque ExtraBold" pitchFamily="34" charset="-120"/>
               </a:rPr>
-              <a:t> ai</a:t>
-            </a:r>
-            <a:r>
-              <a:rPr lang="en-US" sz="6300" dirty="0" spc="-1" kern="0">
+              <a:t> khởi</a:t>
+            </a:r>
+            <a:r>
+              <a:rPr lang="en-US" sz="6300" dirty="0" spc="9" kern="0">
                 <a:solidFill>
                   <a:srgbClr val="F3EEE3"/>
                 </a:solidFill>
@@ -4798,10 +4798,10 @@
                 <a:ea typeface="Bricolage Grotesque ExtraBold" pitchFamily="34" charset="-122"/>
                 <a:cs typeface="Bricolage Grotesque ExtraBold" pitchFamily="34" charset="-120"/>
               </a:rPr>
-              <a:t> cũng</a:t>
-            </a:r>
-            <a:r>
-              <a:rPr lang="en-US" sz="6300" dirty="0" spc="2" kern="0">
+              <a:t> đầu</a:t>
+            </a:r>
+            <a:r>
+              <a:rPr lang="en-US" sz="6300" dirty="0" spc="4" kern="0">
                 <a:solidFill>
                   <a:srgbClr val="F3EEE3"/>
                 </a:solidFill>
@@ -4809,10 +4809,10 @@
                 <a:ea typeface="Bricolage Grotesque ExtraBold" pitchFamily="34" charset="-122"/>
                 <a:cs typeface="Bricolage Grotesque ExtraBold" pitchFamily="34" charset="-120"/>
               </a:rPr>
-              <a:t> chạm</a:t>
-            </a:r>
-            <a:r>
-              <a:rPr lang="en-US" sz="6300" dirty="0" spc="-46" kern="0">
+              <a:t> tiêu</a:t>
+            </a:r>
+            <a:r>
+              <a:rPr lang="en-US" sz="6300" dirty="0" spc="1" kern="0">
                 <a:solidFill>
                   <a:srgbClr val="F3EEE3"/>
                 </a:solidFill>
@@ -4820,7 +4820,7 @@
                 <a:ea typeface="Bricolage Grotesque ExtraBold" pitchFamily="34" charset="-122"/>
                 <a:cs typeface="Bricolage Grotesque ExtraBold" pitchFamily="34" charset="-120"/>
               </a:rPr>
-              <a:t> tới.</a:t>
+              <a:t> biểu.</a:t>
             </a:r>
             <a:endParaRPr lang="en-US" sz="6300" dirty="0"/>
           </a:p>
@@ -5358,239 +5358,14 @@
       </p:sp>
       <p:sp>
         <p:nvSpPr>
-          <p:cNvPr id="12" name="Shape 10"/>
-          <p:cNvSpPr/>
-          <p:nvPr/>
-        </p:nvSpPr>
-        <p:spPr>
-          <a:xfrm>
-            <a:off x="933450" y="9429750"/>
-            <a:ext cx="114300" cy="114300"/>
-          </a:xfrm>
-          <a:prstGeom prst="ellipse">
-            <a:avLst/>
-          </a:prstGeom>
-          <a:solidFill>
-            <a:srgbClr val="F3EEE3"/>
-          </a:solidFill>
-          <a:ln w="19050">
-            <a:solidFill>
-              <a:srgbClr val="F3EEE3"/>
-            </a:solidFill>
-            <a:prstDash val="solid"/>
-          </a:ln>
-        </p:spPr>
-      </p:sp>
-      <p:sp>
-        <p:nvSpPr>
-          <p:cNvPr id="13" name="Shape 11"/>
-          <p:cNvSpPr/>
-          <p:nvPr/>
-        </p:nvSpPr>
-        <p:spPr>
-          <a:xfrm>
-            <a:off x="1257300" y="9429750"/>
-            <a:ext cx="114300" cy="114300"/>
-          </a:xfrm>
-          <a:prstGeom prst="ellipse">
-            <a:avLst/>
-          </a:prstGeom>
-          <a:solidFill>
-            <a:srgbClr val="F3EEE3"/>
-          </a:solidFill>
-          <a:ln w="19050">
-            <a:solidFill>
-              <a:srgbClr val="F3EEE3"/>
-            </a:solidFill>
-            <a:prstDash val="solid"/>
-          </a:ln>
-        </p:spPr>
-      </p:sp>
-      <p:sp>
-        <p:nvSpPr>
-          <p:cNvPr id="14" name="Shape 12"/>
-          <p:cNvSpPr/>
-          <p:nvPr/>
-        </p:nvSpPr>
-        <p:spPr>
-          <a:xfrm>
-            <a:off x="1581150" y="9429750"/>
-            <a:ext cx="114300" cy="114300"/>
-          </a:xfrm>
-          <a:prstGeom prst="ellipse">
-            <a:avLst/>
-          </a:prstGeom>
-          <a:solidFill>
-            <a:srgbClr val="F3EEE3"/>
-          </a:solidFill>
-          <a:ln w="19050">
-            <a:solidFill>
-              <a:srgbClr val="F3EEE3"/>
-            </a:solidFill>
-            <a:prstDash val="solid"/>
-          </a:ln>
-        </p:spPr>
-      </p:sp>
-      <p:sp>
-        <p:nvSpPr>
-          <p:cNvPr id="15" name="Shape 13"/>
-          <p:cNvSpPr/>
-          <p:nvPr/>
-        </p:nvSpPr>
-        <p:spPr>
-          <a:xfrm>
-            <a:off x="1866900" y="9391650"/>
-            <a:ext cx="190500" cy="190500"/>
-          </a:xfrm>
-          <a:prstGeom prst="ellipse">
-            <a:avLst/>
-          </a:prstGeom>
-          <a:solidFill>
-            <a:srgbClr val="FF6A4D"/>
-          </a:solidFill>
-          <a:ln w="19050">
-            <a:solidFill>
-              <a:srgbClr val="FF6A4D"/>
-            </a:solidFill>
-            <a:prstDash val="solid"/>
-          </a:ln>
-        </p:spPr>
-      </p:sp>
-      <p:sp>
-        <p:nvSpPr>
-          <p:cNvPr id="16" name="Shape 14"/>
-          <p:cNvSpPr/>
-          <p:nvPr/>
-        </p:nvSpPr>
-        <p:spPr>
-          <a:xfrm>
-            <a:off x="2228850" y="9429750"/>
-            <a:ext cx="114300" cy="114300"/>
-          </a:xfrm>
-          <a:prstGeom prst="ellipse">
-            <a:avLst/>
-          </a:prstGeom>
-          <a:solidFill>
-            <a:srgbClr val="14161C"/>
-          </a:solidFill>
-          <a:ln w="19050">
-            <a:solidFill>
-              <a:srgbClr val="6B6A66"/>
-            </a:solidFill>
-            <a:prstDash val="solid"/>
-          </a:ln>
-        </p:spPr>
-      </p:sp>
-      <p:sp>
-        <p:nvSpPr>
-          <p:cNvPr id="17" name="Shape 15"/>
-          <p:cNvSpPr/>
-          <p:nvPr/>
-        </p:nvSpPr>
-        <p:spPr>
-          <a:xfrm>
-            <a:off x="2552700" y="9429750"/>
-            <a:ext cx="114300" cy="114300"/>
-          </a:xfrm>
-          <a:prstGeom prst="ellipse">
-            <a:avLst/>
-          </a:prstGeom>
-          <a:solidFill>
-            <a:srgbClr val="14161C"/>
-          </a:solidFill>
-          <a:ln w="19050">
-            <a:solidFill>
-              <a:srgbClr val="6B6A66"/>
-            </a:solidFill>
-            <a:prstDash val="solid"/>
-          </a:ln>
-        </p:spPr>
-      </p:sp>
-      <p:sp>
-        <p:nvSpPr>
-          <p:cNvPr id="18" name="Shape 16"/>
-          <p:cNvSpPr/>
-          <p:nvPr/>
-        </p:nvSpPr>
-        <p:spPr>
-          <a:xfrm>
-            <a:off x="2876550" y="9429750"/>
-            <a:ext cx="114300" cy="114300"/>
-          </a:xfrm>
-          <a:prstGeom prst="ellipse">
-            <a:avLst/>
-          </a:prstGeom>
-          <a:solidFill>
-            <a:srgbClr val="14161C"/>
-          </a:solidFill>
-          <a:ln w="19050">
-            <a:solidFill>
-              <a:srgbClr val="6B6A66"/>
-            </a:solidFill>
-            <a:prstDash val="solid"/>
-          </a:ln>
-        </p:spPr>
-      </p:sp>
-      <p:sp>
-        <p:nvSpPr>
-          <p:cNvPr id="19" name="Shape 17"/>
-          <p:cNvSpPr/>
-          <p:nvPr/>
-        </p:nvSpPr>
-        <p:spPr>
-          <a:xfrm>
-            <a:off x="3200400" y="9429750"/>
-            <a:ext cx="114300" cy="114300"/>
-          </a:xfrm>
-          <a:prstGeom prst="ellipse">
-            <a:avLst/>
-          </a:prstGeom>
-          <a:solidFill>
-            <a:srgbClr val="14161C"/>
-          </a:solidFill>
-          <a:ln w="19050">
-            <a:solidFill>
-              <a:srgbClr val="6B6A66"/>
-            </a:solidFill>
-            <a:prstDash val="solid"/>
-          </a:ln>
-        </p:spPr>
-      </p:sp>
-      <p:sp>
-        <p:nvSpPr>
-          <p:cNvPr id="20" name="Shape 18"/>
-          <p:cNvSpPr/>
-          <p:nvPr/>
-        </p:nvSpPr>
-        <p:spPr>
-          <a:xfrm>
-            <a:off x="3524250" y="9429750"/>
-            <a:ext cx="114300" cy="114300"/>
-          </a:xfrm>
-          <a:prstGeom prst="ellipse">
-            <a:avLst/>
-          </a:prstGeom>
-          <a:solidFill>
-            <a:srgbClr val="14161C"/>
-          </a:solidFill>
-          <a:ln w="19050">
-            <a:solidFill>
-              <a:srgbClr val="6B6A66"/>
-            </a:solidFill>
-            <a:prstDash val="solid"/>
-          </a:ln>
-        </p:spPr>
-      </p:sp>
-      <p:sp>
-        <p:nvSpPr>
-          <p:cNvPr id="21" name="Text 19"/>
-          <p:cNvSpPr/>
-          <p:nvPr/>
-        </p:nvSpPr>
-        <p:spPr>
-          <a:xfrm>
-            <a:off x="914400" y="9715500"/>
-            <a:ext cx="6667500" cy="285750"/>
+          <p:cNvPr id="12" name="Text 10"/>
+          <p:cNvSpPr/>
+          <p:nvPr/>
+        </p:nvSpPr>
+        <p:spPr>
+          <a:xfrm>
+            <a:off x="914400" y="8191500"/>
+            <a:ext cx="16459200" cy="476250"/>
           </a:xfrm>
           <a:prstGeom prst="rect">
             <a:avLst/>
@@ -5606,6 +5381,413 @@
               <a:buNone/>
             </a:pPr>
             <a:r>
+              <a:rPr lang="en-US" sz="2250" dirty="0" spc="0" kern="0">
+                <a:solidFill>
+                  <a:srgbClr val="9AA0B5"/>
+                </a:solidFill>
+                <a:latin typeface="Be Vietnam Pro" pitchFamily="34" charset="0"/>
+                <a:ea typeface="Be Vietnam Pro" pitchFamily="34" charset="-122"/>
+                <a:cs typeface="Be Vietnam Pro" pitchFamily="34" charset="-120"/>
+              </a:rPr>
+              <a:t>Ứng</a:t>
+            </a:r>
+            <a:r>
+              <a:rPr lang="en-US" sz="2250" dirty="0" spc="3" kern="0">
+                <a:solidFill>
+                  <a:srgbClr val="9AA0B5"/>
+                </a:solidFill>
+                <a:latin typeface="Be Vietnam Pro" pitchFamily="34" charset="0"/>
+                <a:ea typeface="Be Vietnam Pro" pitchFamily="34" charset="-122"/>
+                <a:cs typeface="Be Vietnam Pro" pitchFamily="34" charset="-120"/>
+              </a:rPr>
+              <a:t> dụng</a:t>
+            </a:r>
+            <a:r>
+              <a:rPr lang="en-US" sz="2250" dirty="0" spc="1" kern="0">
+                <a:solidFill>
+                  <a:srgbClr val="9AA0B5"/>
+                </a:solidFill>
+                <a:latin typeface="Be Vietnam Pro" pitchFamily="34" charset="0"/>
+                <a:ea typeface="Be Vietnam Pro" pitchFamily="34" charset="-122"/>
+                <a:cs typeface="Be Vietnam Pro" pitchFamily="34" charset="-120"/>
+              </a:rPr>
+              <a:t> không</a:t>
+            </a:r>
+            <a:r>
+              <a:rPr lang="en-US" sz="2250" dirty="0" spc="-10" kern="0">
+                <a:solidFill>
+                  <a:srgbClr val="9AA0B5"/>
+                </a:solidFill>
+                <a:latin typeface="Be Vietnam Pro" pitchFamily="34" charset="0"/>
+                <a:ea typeface="Be Vietnam Pro" pitchFamily="34" charset="-122"/>
+                <a:cs typeface="Be Vietnam Pro" pitchFamily="34" charset="-120"/>
+              </a:rPr>
+              <a:t> máy</a:t>
+            </a:r>
+            <a:r>
+              <a:rPr lang="en-US" sz="2250" dirty="0" spc="3" kern="0">
+                <a:solidFill>
+                  <a:srgbClr val="9AA0B5"/>
+                </a:solidFill>
+                <a:latin typeface="Be Vietnam Pro" pitchFamily="34" charset="0"/>
+                <a:ea typeface="Be Vietnam Pro" pitchFamily="34" charset="-122"/>
+                <a:cs typeface="Be Vietnam Pro" pitchFamily="34" charset="-120"/>
+              </a:rPr>
+              <a:t> chủ</a:t>
+            </a:r>
+            <a:r>
+              <a:rPr lang="en-US" sz="2250" dirty="0" spc="5" kern="0">
+                <a:solidFill>
+                  <a:srgbClr val="9AA0B5"/>
+                </a:solidFill>
+                <a:latin typeface="Be Vietnam Pro" pitchFamily="34" charset="0"/>
+                <a:ea typeface="Be Vietnam Pro" pitchFamily="34" charset="-122"/>
+                <a:cs typeface="Be Vietnam Pro" pitchFamily="34" charset="-120"/>
+              </a:rPr>
+              <a:t> có</a:t>
+            </a:r>
+            <a:r>
+              <a:rPr lang="en-US" sz="2250" dirty="0" spc="0" kern="0">
+                <a:solidFill>
+                  <a:srgbClr val="9AA0B5"/>
+                </a:solidFill>
+                <a:latin typeface="Be Vietnam Pro" pitchFamily="34" charset="0"/>
+                <a:ea typeface="Be Vietnam Pro" pitchFamily="34" charset="-122"/>
+                <a:cs typeface="Be Vietnam Pro" pitchFamily="34" charset="-120"/>
+              </a:rPr>
+              <a:t> thể</a:t>
+            </a:r>
+            <a:r>
+              <a:rPr lang="en-US" sz="2250" dirty="0" spc="1" kern="0">
+                <a:solidFill>
+                  <a:srgbClr val="9AA0B5"/>
+                </a:solidFill>
+                <a:latin typeface="Be Vietnam Pro" pitchFamily="34" charset="0"/>
+                <a:ea typeface="Be Vietnam Pro" pitchFamily="34" charset="-122"/>
+                <a:cs typeface="Be Vietnam Pro" pitchFamily="34" charset="-120"/>
+              </a:rPr>
+              <a:t> không</a:t>
+            </a:r>
+            <a:r>
+              <a:rPr lang="en-US" sz="2250" dirty="0" spc="2" kern="0">
+                <a:solidFill>
+                  <a:srgbClr val="9AA0B5"/>
+                </a:solidFill>
+                <a:latin typeface="Be Vietnam Pro" pitchFamily="34" charset="0"/>
+                <a:ea typeface="Be Vietnam Pro" pitchFamily="34" charset="-122"/>
+                <a:cs typeface="Be Vietnam Pro" pitchFamily="34" charset="-120"/>
+              </a:rPr>
+              <a:t> dùng</a:t>
+            </a:r>
+            <a:r>
+              <a:rPr lang="en-US" sz="2250" dirty="0" spc="9" kern="0">
+                <a:solidFill>
+                  <a:srgbClr val="9AA0B5"/>
+                </a:solidFill>
+                <a:latin typeface="Be Vietnam Pro" pitchFamily="34" charset="0"/>
+                <a:ea typeface="Be Vietnam Pro" pitchFamily="34" charset="-122"/>
+                <a:cs typeface="Be Vietnam Pro" pitchFamily="34" charset="-120"/>
+              </a:rPr>
+              <a:t> trực</a:t>
+            </a:r>
+            <a:r>
+              <a:rPr lang="en-US" sz="2250" dirty="0" spc="0" kern="0">
+                <a:solidFill>
+                  <a:srgbClr val="9AA0B5"/>
+                </a:solidFill>
+                <a:latin typeface="Be Vietnam Pro" pitchFamily="34" charset="0"/>
+                <a:ea typeface="Be Vietnam Pro" pitchFamily="34" charset="-122"/>
+                <a:cs typeface="Be Vietnam Pro" pitchFamily="34" charset="-120"/>
+              </a:rPr>
+              <a:t> tiếp</a:t>
+            </a:r>
+            <a:r>
+              <a:rPr lang="en-US" sz="2250" dirty="0" spc="-2" kern="0">
+                <a:solidFill>
+                  <a:srgbClr val="9AA0B5"/>
+                </a:solidFill>
+                <a:latin typeface="Be Vietnam Pro" pitchFamily="34" charset="0"/>
+                <a:ea typeface="Be Vietnam Pro" pitchFamily="34" charset="-122"/>
+                <a:cs typeface="Be Vietnam Pro" pitchFamily="34" charset="-120"/>
+              </a:rPr>
+              <a:t> EC2,</a:t>
+            </a:r>
+            <a:r>
+              <a:rPr lang="en-US" sz="2250" dirty="0" spc="0" kern="0">
+                <a:solidFill>
+                  <a:srgbClr val="9AA0B5"/>
+                </a:solidFill>
+                <a:latin typeface="Be Vietnam Pro" pitchFamily="34" charset="0"/>
+                <a:ea typeface="Be Vietnam Pro" pitchFamily="34" charset="-122"/>
+                <a:cs typeface="Be Vietnam Pro" pitchFamily="34" charset="-120"/>
+              </a:rPr>
+              <a:t> S3,</a:t>
+            </a:r>
+            <a:r>
+              <a:rPr lang="en-US" sz="2250" dirty="0" spc="1" kern="0">
+                <a:solidFill>
+                  <a:srgbClr val="9AA0B5"/>
+                </a:solidFill>
+                <a:latin typeface="Be Vietnam Pro" pitchFamily="34" charset="0"/>
+                <a:ea typeface="Be Vietnam Pro" pitchFamily="34" charset="-122"/>
+                <a:cs typeface="Be Vietnam Pro" pitchFamily="34" charset="-120"/>
+              </a:rPr>
+              <a:t> VPC.</a:t>
+            </a:r>
+            <a:endParaRPr lang="en-US" sz="2250" dirty="0"/>
+          </a:p>
+        </p:txBody>
+      </p:sp>
+      <p:sp>
+        <p:nvSpPr>
+          <p:cNvPr id="13" name="Shape 11"/>
+          <p:cNvSpPr/>
+          <p:nvPr/>
+        </p:nvSpPr>
+        <p:spPr>
+          <a:xfrm>
+            <a:off x="933450" y="9429750"/>
+            <a:ext cx="114300" cy="114300"/>
+          </a:xfrm>
+          <a:prstGeom prst="ellipse">
+            <a:avLst/>
+          </a:prstGeom>
+          <a:solidFill>
+            <a:srgbClr val="F3EEE3"/>
+          </a:solidFill>
+          <a:ln w="19050">
+            <a:solidFill>
+              <a:srgbClr val="F3EEE3"/>
+            </a:solidFill>
+            <a:prstDash val="solid"/>
+          </a:ln>
+        </p:spPr>
+      </p:sp>
+      <p:sp>
+        <p:nvSpPr>
+          <p:cNvPr id="14" name="Shape 12"/>
+          <p:cNvSpPr/>
+          <p:nvPr/>
+        </p:nvSpPr>
+        <p:spPr>
+          <a:xfrm>
+            <a:off x="1257300" y="9429750"/>
+            <a:ext cx="114300" cy="114300"/>
+          </a:xfrm>
+          <a:prstGeom prst="ellipse">
+            <a:avLst/>
+          </a:prstGeom>
+          <a:solidFill>
+            <a:srgbClr val="F3EEE3"/>
+          </a:solidFill>
+          <a:ln w="19050">
+            <a:solidFill>
+              <a:srgbClr val="F3EEE3"/>
+            </a:solidFill>
+            <a:prstDash val="solid"/>
+          </a:ln>
+        </p:spPr>
+      </p:sp>
+      <p:sp>
+        <p:nvSpPr>
+          <p:cNvPr id="15" name="Shape 13"/>
+          <p:cNvSpPr/>
+          <p:nvPr/>
+        </p:nvSpPr>
+        <p:spPr>
+          <a:xfrm>
+            <a:off x="1581150" y="9429750"/>
+            <a:ext cx="114300" cy="114300"/>
+          </a:xfrm>
+          <a:prstGeom prst="ellipse">
+            <a:avLst/>
+          </a:prstGeom>
+          <a:solidFill>
+            <a:srgbClr val="F3EEE3"/>
+          </a:solidFill>
+          <a:ln w="19050">
+            <a:solidFill>
+              <a:srgbClr val="F3EEE3"/>
+            </a:solidFill>
+            <a:prstDash val="solid"/>
+          </a:ln>
+        </p:spPr>
+      </p:sp>
+      <p:sp>
+        <p:nvSpPr>
+          <p:cNvPr id="16" name="Shape 14"/>
+          <p:cNvSpPr/>
+          <p:nvPr/>
+        </p:nvSpPr>
+        <p:spPr>
+          <a:xfrm>
+            <a:off x="1866900" y="9391650"/>
+            <a:ext cx="190500" cy="190500"/>
+          </a:xfrm>
+          <a:prstGeom prst="ellipse">
+            <a:avLst/>
+          </a:prstGeom>
+          <a:solidFill>
+            <a:srgbClr val="FF6A4D"/>
+          </a:solidFill>
+          <a:ln w="19050">
+            <a:solidFill>
+              <a:srgbClr val="FF6A4D"/>
+            </a:solidFill>
+            <a:prstDash val="solid"/>
+          </a:ln>
+        </p:spPr>
+      </p:sp>
+      <p:sp>
+        <p:nvSpPr>
+          <p:cNvPr id="17" name="Shape 15"/>
+          <p:cNvSpPr/>
+          <p:nvPr/>
+        </p:nvSpPr>
+        <p:spPr>
+          <a:xfrm>
+            <a:off x="2228850" y="9429750"/>
+            <a:ext cx="114300" cy="114300"/>
+          </a:xfrm>
+          <a:prstGeom prst="ellipse">
+            <a:avLst/>
+          </a:prstGeom>
+          <a:solidFill>
+            <a:srgbClr val="14161C"/>
+          </a:solidFill>
+          <a:ln w="19050">
+            <a:solidFill>
+              <a:srgbClr val="6B6A66"/>
+            </a:solidFill>
+            <a:prstDash val="solid"/>
+          </a:ln>
+        </p:spPr>
+      </p:sp>
+      <p:sp>
+        <p:nvSpPr>
+          <p:cNvPr id="18" name="Shape 16"/>
+          <p:cNvSpPr/>
+          <p:nvPr/>
+        </p:nvSpPr>
+        <p:spPr>
+          <a:xfrm>
+            <a:off x="2552700" y="9429750"/>
+            <a:ext cx="114300" cy="114300"/>
+          </a:xfrm>
+          <a:prstGeom prst="ellipse">
+            <a:avLst/>
+          </a:prstGeom>
+          <a:solidFill>
+            <a:srgbClr val="14161C"/>
+          </a:solidFill>
+          <a:ln w="19050">
+            <a:solidFill>
+              <a:srgbClr val="6B6A66"/>
+            </a:solidFill>
+            <a:prstDash val="solid"/>
+          </a:ln>
+        </p:spPr>
+      </p:sp>
+      <p:sp>
+        <p:nvSpPr>
+          <p:cNvPr id="19" name="Shape 17"/>
+          <p:cNvSpPr/>
+          <p:nvPr/>
+        </p:nvSpPr>
+        <p:spPr>
+          <a:xfrm>
+            <a:off x="2876550" y="9429750"/>
+            <a:ext cx="114300" cy="114300"/>
+          </a:xfrm>
+          <a:prstGeom prst="ellipse">
+            <a:avLst/>
+          </a:prstGeom>
+          <a:solidFill>
+            <a:srgbClr val="14161C"/>
+          </a:solidFill>
+          <a:ln w="19050">
+            <a:solidFill>
+              <a:srgbClr val="6B6A66"/>
+            </a:solidFill>
+            <a:prstDash val="solid"/>
+          </a:ln>
+        </p:spPr>
+      </p:sp>
+      <p:sp>
+        <p:nvSpPr>
+          <p:cNvPr id="20" name="Shape 18"/>
+          <p:cNvSpPr/>
+          <p:nvPr/>
+        </p:nvSpPr>
+        <p:spPr>
+          <a:xfrm>
+            <a:off x="3200400" y="9429750"/>
+            <a:ext cx="114300" cy="114300"/>
+          </a:xfrm>
+          <a:prstGeom prst="ellipse">
+            <a:avLst/>
+          </a:prstGeom>
+          <a:solidFill>
+            <a:srgbClr val="14161C"/>
+          </a:solidFill>
+          <a:ln w="19050">
+            <a:solidFill>
+              <a:srgbClr val="6B6A66"/>
+            </a:solidFill>
+            <a:prstDash val="solid"/>
+          </a:ln>
+        </p:spPr>
+      </p:sp>
+      <p:sp>
+        <p:nvSpPr>
+          <p:cNvPr id="21" name="Shape 19"/>
+          <p:cNvSpPr/>
+          <p:nvPr/>
+        </p:nvSpPr>
+        <p:spPr>
+          <a:xfrm>
+            <a:off x="3524250" y="9429750"/>
+            <a:ext cx="114300" cy="114300"/>
+          </a:xfrm>
+          <a:prstGeom prst="ellipse">
+            <a:avLst/>
+          </a:prstGeom>
+          <a:solidFill>
+            <a:srgbClr val="14161C"/>
+          </a:solidFill>
+          <a:ln w="19050">
+            <a:solidFill>
+              <a:srgbClr val="6B6A66"/>
+            </a:solidFill>
+            <a:prstDash val="solid"/>
+          </a:ln>
+        </p:spPr>
+      </p:sp>
+      <p:sp>
+        <p:nvSpPr>
+          <p:cNvPr id="22" name="Text 20"/>
+          <p:cNvSpPr/>
+          <p:nvPr/>
+        </p:nvSpPr>
+        <p:spPr>
+          <a:xfrm>
+            <a:off x="914400" y="9715500"/>
+            <a:ext cx="6667500" cy="285750"/>
+          </a:xfrm>
+          <a:prstGeom prst="rect">
+            <a:avLst/>
+          </a:prstGeom>
+          <a:noFill/>
+          <a:ln/>
+        </p:spPr>
+        <p:txBody>
+          <a:bodyPr wrap="square" lIns="0" tIns="0" rIns="0" bIns="0" rtlCol="0" anchor="t"/>
+          <a:lstStyle/>
+          <a:p>
+            <a:pPr algn="l" indent="0" marL="0">
+              <a:buNone/>
+            </a:pPr>
+            <a:r>
               <a:rPr lang="en-US" sz="1650" dirty="0" spc="-12" kern="0">
                 <a:solidFill>
                   <a:srgbClr val="9AA0B5"/>
@@ -5699,7 +5881,7 @@
       </p:sp>
       <p:sp>
         <p:nvSpPr>
-          <p:cNvPr id="22" name="Shape 20"/>
+          <p:cNvPr id="23" name="Shape 21"/>
           <p:cNvSpPr/>
           <p:nvPr/>
         </p:nvSpPr>
@@ -5723,7 +5905,7 @@
       </p:sp>
       <p:pic>
         <p:nvPicPr>
-          <p:cNvPr id="23" name="Moda image moda-export-watermark-8edad603-8232-435c-ac73-09bb87ea4dc5" descr="">    </p:cNvPr>
+          <p:cNvPr id="24" name="Moda image moda-export-watermark-8edad603-8232-435c-ac73-09bb87ea4dc5" descr="">    </p:cNvPr>
           <p:cNvPicPr>
             <a:picLocks noChangeAspect="1"/>
           </p:cNvPicPr>

</xml_diff>